<commit_message>
raw data- CMV journal
</commit_message>
<xml_diff>
--- a/Switching Function - Reduced CMV PWM/Access-paper/Imperix/raw_data/New Microsoft PowerPoint Presentation.pptx
+++ b/Switching Function - Reduced CMV PWM/Access-paper/Imperix/raw_data/New Microsoft PowerPoint Presentation.pptx
@@ -6,6 +6,10 @@
   </p:sldMasterIdLst>
   <p:sldIdLst>
     <p:sldId id="256" r:id="rId2"/>
+    <p:sldId id="257" r:id="rId3"/>
+    <p:sldId id="260" r:id="rId4"/>
+    <p:sldId id="258" r:id="rId5"/>
+    <p:sldId id="259" r:id="rId6"/>
   </p:sldIdLst>
   <p:sldSz cx="12192000" cy="6858000"/>
   <p:notesSz cx="6858000" cy="9144000"/>
@@ -3008,7 +3012,7 @@
         </p:nvSpPr>
         <p:spPr>
           <a:xfrm>
-            <a:off x="5397500" y="6875939"/>
+            <a:off x="5397500" y="6858000"/>
             <a:ext cx="632460" cy="400110"/>
           </a:xfrm>
           <a:prstGeom prst="rect">
@@ -3086,6 +3090,595 @@
     <p:extLst>
       <p:ext uri="{BB962C8B-B14F-4D97-AF65-F5344CB8AC3E}">
         <p14:creationId xmlns:p14="http://schemas.microsoft.com/office/powerpoint/2010/main" val="3021390343"/>
+      </p:ext>
+    </p:extLst>
+  </p:cSld>
+  <p:clrMapOvr>
+    <a:masterClrMapping/>
+  </p:clrMapOvr>
+</p:sld>
+</file>
+
+<file path=ppt/slides/slide2.xml><?xml version="1.0" encoding="utf-8"?>
+<p:sld xmlns:a="http://schemas.openxmlformats.org/drawingml/2006/main" xmlns:r="http://schemas.openxmlformats.org/officeDocument/2006/relationships" xmlns:p="http://schemas.openxmlformats.org/presentationml/2006/main">
+  <p:cSld>
+    <p:spTree>
+      <p:nvGrpSpPr>
+        <p:cNvPr id="1" name=""/>
+        <p:cNvGrpSpPr/>
+        <p:nvPr/>
+      </p:nvGrpSpPr>
+      <p:grpSpPr>
+        <a:xfrm>
+          <a:off x="0" y="0"/>
+          <a:ext cx="0" cy="0"/>
+          <a:chOff x="0" y="0"/>
+          <a:chExt cx="0" cy="0"/>
+        </a:xfrm>
+      </p:grpSpPr>
+      <p:sp>
+        <p:nvSpPr>
+          <p:cNvPr id="7" name="TextBox 6"/>
+          <p:cNvSpPr txBox="1"/>
+          <p:nvPr/>
+        </p:nvSpPr>
+        <p:spPr>
+          <a:xfrm>
+            <a:off x="5397500" y="2963723"/>
+            <a:ext cx="632460" cy="400110"/>
+          </a:xfrm>
+          <a:prstGeom prst="rect">
+            <a:avLst/>
+          </a:prstGeom>
+          <a:noFill/>
+        </p:spPr>
+        <p:txBody>
+          <a:bodyPr wrap="square" rtlCol="0">
+            <a:spAutoFit/>
+          </a:bodyPr>
+          <a:lstStyle/>
+          <a:p>
+            <a:r>
+              <a:rPr lang="en-US" sz="2000" dirty="0" smtClean="0">
+                <a:latin typeface="Times New Roman" panose="02020603050405020304" pitchFamily="18" charset="0"/>
+                <a:cs typeface="Times New Roman" panose="02020603050405020304" pitchFamily="18" charset="0"/>
+              </a:rPr>
+              <a:t>(a)</a:t>
+            </a:r>
+            <a:endParaRPr lang="sv-SE" sz="2000" dirty="0">
+              <a:latin typeface="Times New Roman" panose="02020603050405020304" pitchFamily="18" charset="0"/>
+              <a:cs typeface="Times New Roman" panose="02020603050405020304" pitchFamily="18" charset="0"/>
+            </a:endParaRPr>
+          </a:p>
+        </p:txBody>
+      </p:sp>
+      <p:sp>
+        <p:nvSpPr>
+          <p:cNvPr id="8" name="TextBox 7"/>
+          <p:cNvSpPr txBox="1"/>
+          <p:nvPr/>
+        </p:nvSpPr>
+        <p:spPr>
+          <a:xfrm>
+            <a:off x="5397500" y="6858000"/>
+            <a:ext cx="632460" cy="400110"/>
+          </a:xfrm>
+          <a:prstGeom prst="rect">
+            <a:avLst/>
+          </a:prstGeom>
+          <a:noFill/>
+        </p:spPr>
+        <p:txBody>
+          <a:bodyPr wrap="square" rtlCol="0">
+            <a:spAutoFit/>
+          </a:bodyPr>
+          <a:lstStyle/>
+          <a:p>
+            <a:r>
+              <a:rPr lang="en-US" sz="2000" dirty="0" smtClean="0">
+                <a:latin typeface="Times New Roman" panose="02020603050405020304" pitchFamily="18" charset="0"/>
+                <a:cs typeface="Times New Roman" panose="02020603050405020304" pitchFamily="18" charset="0"/>
+              </a:rPr>
+              <a:t>(b)</a:t>
+            </a:r>
+            <a:endParaRPr lang="sv-SE" sz="2000" dirty="0">
+              <a:latin typeface="Times New Roman" panose="02020603050405020304" pitchFamily="18" charset="0"/>
+              <a:cs typeface="Times New Roman" panose="02020603050405020304" pitchFamily="18" charset="0"/>
+            </a:endParaRPr>
+          </a:p>
+        </p:txBody>
+      </p:sp>
+      <p:pic>
+        <p:nvPicPr>
+          <p:cNvPr id="2" name="Picture 1"/>
+          <p:cNvPicPr>
+            <a:picLocks noChangeAspect="1"/>
+          </p:cNvPicPr>
+          <p:nvPr/>
+        </p:nvPicPr>
+        <p:blipFill rotWithShape="1">
+          <a:blip r:embed="rId2"/>
+          <a:srcRect l="5201" t="6741" r="8299" b="15250"/>
+          <a:stretch/>
+        </p:blipFill>
+        <p:spPr>
+          <a:xfrm>
+            <a:off x="1209675" y="9525"/>
+            <a:ext cx="8239125" cy="2972137"/>
+          </a:xfrm>
+          <a:prstGeom prst="rect">
+            <a:avLst/>
+          </a:prstGeom>
+        </p:spPr>
+      </p:pic>
+      <p:pic>
+        <p:nvPicPr>
+          <p:cNvPr id="3" name="Picture 2"/>
+          <p:cNvPicPr>
+            <a:picLocks noChangeAspect="1"/>
+          </p:cNvPicPr>
+          <p:nvPr/>
+        </p:nvPicPr>
+        <p:blipFill rotWithShape="1">
+          <a:blip r:embed="rId3"/>
+          <a:srcRect l="5600" r="8300"/>
+          <a:stretch/>
+        </p:blipFill>
+        <p:spPr>
+          <a:xfrm>
+            <a:off x="1266825" y="3048000"/>
+            <a:ext cx="8201025" cy="3810000"/>
+          </a:xfrm>
+          <a:prstGeom prst="rect">
+            <a:avLst/>
+          </a:prstGeom>
+        </p:spPr>
+      </p:pic>
+    </p:spTree>
+    <p:extLst>
+      <p:ext uri="{BB962C8B-B14F-4D97-AF65-F5344CB8AC3E}">
+        <p14:creationId xmlns:p14="http://schemas.microsoft.com/office/powerpoint/2010/main" val="2122041870"/>
+      </p:ext>
+    </p:extLst>
+  </p:cSld>
+  <p:clrMapOvr>
+    <a:masterClrMapping/>
+  </p:clrMapOvr>
+</p:sld>
+</file>
+
+<file path=ppt/slides/slide3.xml><?xml version="1.0" encoding="utf-8"?>
+<p:sld xmlns:a="http://schemas.openxmlformats.org/drawingml/2006/main" xmlns:r="http://schemas.openxmlformats.org/officeDocument/2006/relationships" xmlns:p="http://schemas.openxmlformats.org/presentationml/2006/main">
+  <p:cSld>
+    <p:spTree>
+      <p:nvGrpSpPr>
+        <p:cNvPr id="1" name=""/>
+        <p:cNvGrpSpPr/>
+        <p:nvPr/>
+      </p:nvGrpSpPr>
+      <p:grpSpPr>
+        <a:xfrm>
+          <a:off x="0" y="0"/>
+          <a:ext cx="0" cy="0"/>
+          <a:chOff x="0" y="0"/>
+          <a:chExt cx="0" cy="0"/>
+        </a:xfrm>
+      </p:grpSpPr>
+      <p:sp>
+        <p:nvSpPr>
+          <p:cNvPr id="7" name="TextBox 6"/>
+          <p:cNvSpPr txBox="1"/>
+          <p:nvPr/>
+        </p:nvSpPr>
+        <p:spPr>
+          <a:xfrm>
+            <a:off x="5397500" y="2963723"/>
+            <a:ext cx="632460" cy="400110"/>
+          </a:xfrm>
+          <a:prstGeom prst="rect">
+            <a:avLst/>
+          </a:prstGeom>
+          <a:noFill/>
+        </p:spPr>
+        <p:txBody>
+          <a:bodyPr wrap="square" rtlCol="0">
+            <a:spAutoFit/>
+          </a:bodyPr>
+          <a:lstStyle/>
+          <a:p>
+            <a:r>
+              <a:rPr lang="en-US" sz="2000" dirty="0" smtClean="0">
+                <a:latin typeface="Times New Roman" panose="02020603050405020304" pitchFamily="18" charset="0"/>
+                <a:cs typeface="Times New Roman" panose="02020603050405020304" pitchFamily="18" charset="0"/>
+              </a:rPr>
+              <a:t>(a)</a:t>
+            </a:r>
+            <a:endParaRPr lang="sv-SE" sz="2000" dirty="0">
+              <a:latin typeface="Times New Roman" panose="02020603050405020304" pitchFamily="18" charset="0"/>
+              <a:cs typeface="Times New Roman" panose="02020603050405020304" pitchFamily="18" charset="0"/>
+            </a:endParaRPr>
+          </a:p>
+        </p:txBody>
+      </p:sp>
+      <p:sp>
+        <p:nvSpPr>
+          <p:cNvPr id="8" name="TextBox 7"/>
+          <p:cNvSpPr txBox="1"/>
+          <p:nvPr/>
+        </p:nvSpPr>
+        <p:spPr>
+          <a:xfrm>
+            <a:off x="5397500" y="6858000"/>
+            <a:ext cx="632460" cy="400110"/>
+          </a:xfrm>
+          <a:prstGeom prst="rect">
+            <a:avLst/>
+          </a:prstGeom>
+          <a:noFill/>
+        </p:spPr>
+        <p:txBody>
+          <a:bodyPr wrap="square" rtlCol="0">
+            <a:spAutoFit/>
+          </a:bodyPr>
+          <a:lstStyle/>
+          <a:p>
+            <a:r>
+              <a:rPr lang="en-US" sz="2000" dirty="0" smtClean="0">
+                <a:latin typeface="Times New Roman" panose="02020603050405020304" pitchFamily="18" charset="0"/>
+                <a:cs typeface="Times New Roman" panose="02020603050405020304" pitchFamily="18" charset="0"/>
+              </a:rPr>
+              <a:t>(b)</a:t>
+            </a:r>
+            <a:endParaRPr lang="sv-SE" sz="2000" dirty="0">
+              <a:latin typeface="Times New Roman" panose="02020603050405020304" pitchFamily="18" charset="0"/>
+              <a:cs typeface="Times New Roman" panose="02020603050405020304" pitchFamily="18" charset="0"/>
+            </a:endParaRPr>
+          </a:p>
+        </p:txBody>
+      </p:sp>
+      <p:pic>
+        <p:nvPicPr>
+          <p:cNvPr id="2" name="Picture 1"/>
+          <p:cNvPicPr>
+            <a:picLocks noChangeAspect="1"/>
+          </p:cNvPicPr>
+          <p:nvPr/>
+        </p:nvPicPr>
+        <p:blipFill rotWithShape="1">
+          <a:blip r:embed="rId2"/>
+          <a:srcRect l="8801" t="6741" r="8299" b="15250"/>
+          <a:stretch/>
+        </p:blipFill>
+        <p:spPr>
+          <a:xfrm>
+            <a:off x="1552575" y="9525"/>
+            <a:ext cx="7896225" cy="2972137"/>
+          </a:xfrm>
+          <a:prstGeom prst="rect">
+            <a:avLst/>
+          </a:prstGeom>
+        </p:spPr>
+      </p:pic>
+      <p:pic>
+        <p:nvPicPr>
+          <p:cNvPr id="4" name="Picture 3"/>
+          <p:cNvPicPr>
+            <a:picLocks noChangeAspect="1"/>
+          </p:cNvPicPr>
+          <p:nvPr/>
+        </p:nvPicPr>
+        <p:blipFill rotWithShape="1">
+          <a:blip r:embed="rId3"/>
+          <a:srcRect l="7598" r="7602"/>
+          <a:stretch/>
+        </p:blipFill>
+        <p:spPr>
+          <a:xfrm>
+            <a:off x="1428750" y="3048000"/>
+            <a:ext cx="8077199" cy="3810000"/>
+          </a:xfrm>
+          <a:prstGeom prst="rect">
+            <a:avLst/>
+          </a:prstGeom>
+        </p:spPr>
+      </p:pic>
+      <p:pic>
+        <p:nvPicPr>
+          <p:cNvPr id="9" name="Picture 8"/>
+          <p:cNvPicPr>
+            <a:picLocks noChangeAspect="1"/>
+          </p:cNvPicPr>
+          <p:nvPr/>
+        </p:nvPicPr>
+        <p:blipFill rotWithShape="1">
+          <a:blip r:embed="rId2"/>
+          <a:srcRect l="5201" t="6741" r="91299" b="15250"/>
+          <a:stretch/>
+        </p:blipFill>
+        <p:spPr>
+          <a:xfrm>
+            <a:off x="1095375" y="-15195"/>
+            <a:ext cx="333375" cy="2972137"/>
+          </a:xfrm>
+          <a:prstGeom prst="rect">
+            <a:avLst/>
+          </a:prstGeom>
+        </p:spPr>
+      </p:pic>
+      <p:pic>
+        <p:nvPicPr>
+          <p:cNvPr id="10" name="Picture 9"/>
+          <p:cNvPicPr>
+            <a:picLocks noChangeAspect="1"/>
+          </p:cNvPicPr>
+          <p:nvPr/>
+        </p:nvPicPr>
+        <p:blipFill rotWithShape="1">
+          <a:blip r:embed="rId2"/>
+          <a:srcRect l="5201" t="6741" r="91299" b="15250"/>
+          <a:stretch/>
+        </p:blipFill>
+        <p:spPr>
+          <a:xfrm>
+            <a:off x="1095375" y="3230116"/>
+            <a:ext cx="333375" cy="2972137"/>
+          </a:xfrm>
+          <a:prstGeom prst="rect">
+            <a:avLst/>
+          </a:prstGeom>
+        </p:spPr>
+      </p:pic>
+    </p:spTree>
+    <p:extLst>
+      <p:ext uri="{BB962C8B-B14F-4D97-AF65-F5344CB8AC3E}">
+        <p14:creationId xmlns:p14="http://schemas.microsoft.com/office/powerpoint/2010/main" val="3814011159"/>
+      </p:ext>
+    </p:extLst>
+  </p:cSld>
+  <p:clrMapOvr>
+    <a:masterClrMapping/>
+  </p:clrMapOvr>
+</p:sld>
+</file>
+
+<file path=ppt/slides/slide4.xml><?xml version="1.0" encoding="utf-8"?>
+<p:sld xmlns:a="http://schemas.openxmlformats.org/drawingml/2006/main" xmlns:r="http://schemas.openxmlformats.org/officeDocument/2006/relationships" xmlns:p="http://schemas.openxmlformats.org/presentationml/2006/main">
+  <p:cSld>
+    <p:spTree>
+      <p:nvGrpSpPr>
+        <p:cNvPr id="1" name=""/>
+        <p:cNvGrpSpPr/>
+        <p:nvPr/>
+      </p:nvGrpSpPr>
+      <p:grpSpPr>
+        <a:xfrm>
+          <a:off x="0" y="0"/>
+          <a:ext cx="0" cy="0"/>
+          <a:chOff x="0" y="0"/>
+          <a:chExt cx="0" cy="0"/>
+        </a:xfrm>
+      </p:grpSpPr>
+      <p:pic>
+        <p:nvPicPr>
+          <p:cNvPr id="4" name="Picture 3"/>
+          <p:cNvPicPr>
+            <a:picLocks noChangeAspect="1"/>
+          </p:cNvPicPr>
+          <p:nvPr/>
+        </p:nvPicPr>
+        <p:blipFill rotWithShape="1">
+          <a:blip r:embed="rId2"/>
+          <a:srcRect l="5700" t="5250" r="7700"/>
+          <a:stretch/>
+        </p:blipFill>
+        <p:spPr>
+          <a:xfrm>
+            <a:off x="1876424" y="1724024"/>
+            <a:ext cx="8248651" cy="3609975"/>
+          </a:xfrm>
+          <a:prstGeom prst="rect">
+            <a:avLst/>
+          </a:prstGeom>
+        </p:spPr>
+      </p:pic>
+    </p:spTree>
+    <p:extLst>
+      <p:ext uri="{BB962C8B-B14F-4D97-AF65-F5344CB8AC3E}">
+        <p14:creationId xmlns:p14="http://schemas.microsoft.com/office/powerpoint/2010/main" val="1669249909"/>
+      </p:ext>
+    </p:extLst>
+  </p:cSld>
+  <p:clrMapOvr>
+    <a:masterClrMapping/>
+  </p:clrMapOvr>
+</p:sld>
+</file>
+
+<file path=ppt/slides/slide5.xml><?xml version="1.0" encoding="utf-8"?>
+<p:sld xmlns:a="http://schemas.openxmlformats.org/drawingml/2006/main" xmlns:r="http://schemas.openxmlformats.org/officeDocument/2006/relationships" xmlns:p="http://schemas.openxmlformats.org/presentationml/2006/main">
+  <p:cSld>
+    <p:spTree>
+      <p:nvGrpSpPr>
+        <p:cNvPr id="1" name=""/>
+        <p:cNvGrpSpPr/>
+        <p:nvPr/>
+      </p:nvGrpSpPr>
+      <p:grpSpPr>
+        <a:xfrm>
+          <a:off x="0" y="0"/>
+          <a:ext cx="0" cy="0"/>
+          <a:chOff x="0" y="0"/>
+          <a:chExt cx="0" cy="0"/>
+        </a:xfrm>
+      </p:grpSpPr>
+      <p:sp>
+        <p:nvSpPr>
+          <p:cNvPr id="7" name="TextBox 6"/>
+          <p:cNvSpPr txBox="1"/>
+          <p:nvPr/>
+        </p:nvSpPr>
+        <p:spPr>
+          <a:xfrm>
+            <a:off x="5397500" y="2963723"/>
+            <a:ext cx="632460" cy="400110"/>
+          </a:xfrm>
+          <a:prstGeom prst="rect">
+            <a:avLst/>
+          </a:prstGeom>
+          <a:noFill/>
+        </p:spPr>
+        <p:txBody>
+          <a:bodyPr wrap="square" rtlCol="0">
+            <a:spAutoFit/>
+          </a:bodyPr>
+          <a:lstStyle/>
+          <a:p>
+            <a:r>
+              <a:rPr lang="en-US" sz="2000" dirty="0" smtClean="0">
+                <a:latin typeface="Times New Roman" panose="02020603050405020304" pitchFamily="18" charset="0"/>
+                <a:cs typeface="Times New Roman" panose="02020603050405020304" pitchFamily="18" charset="0"/>
+              </a:rPr>
+              <a:t>(a)</a:t>
+            </a:r>
+            <a:endParaRPr lang="sv-SE" sz="2000" dirty="0">
+              <a:latin typeface="Times New Roman" panose="02020603050405020304" pitchFamily="18" charset="0"/>
+              <a:cs typeface="Times New Roman" panose="02020603050405020304" pitchFamily="18" charset="0"/>
+            </a:endParaRPr>
+          </a:p>
+        </p:txBody>
+      </p:sp>
+      <p:sp>
+        <p:nvSpPr>
+          <p:cNvPr id="8" name="TextBox 7"/>
+          <p:cNvSpPr txBox="1"/>
+          <p:nvPr/>
+        </p:nvSpPr>
+        <p:spPr>
+          <a:xfrm>
+            <a:off x="5397500" y="6858000"/>
+            <a:ext cx="632460" cy="400110"/>
+          </a:xfrm>
+          <a:prstGeom prst="rect">
+            <a:avLst/>
+          </a:prstGeom>
+          <a:noFill/>
+        </p:spPr>
+        <p:txBody>
+          <a:bodyPr wrap="square" rtlCol="0">
+            <a:spAutoFit/>
+          </a:bodyPr>
+          <a:lstStyle/>
+          <a:p>
+            <a:r>
+              <a:rPr lang="en-US" sz="2000" dirty="0" smtClean="0">
+                <a:latin typeface="Times New Roman" panose="02020603050405020304" pitchFamily="18" charset="0"/>
+                <a:cs typeface="Times New Roman" panose="02020603050405020304" pitchFamily="18" charset="0"/>
+              </a:rPr>
+              <a:t>(b)</a:t>
+            </a:r>
+            <a:endParaRPr lang="sv-SE" sz="2000" dirty="0">
+              <a:latin typeface="Times New Roman" panose="02020603050405020304" pitchFamily="18" charset="0"/>
+              <a:cs typeface="Times New Roman" panose="02020603050405020304" pitchFamily="18" charset="0"/>
+            </a:endParaRPr>
+          </a:p>
+        </p:txBody>
+      </p:sp>
+      <p:pic>
+        <p:nvPicPr>
+          <p:cNvPr id="4" name="Picture 3"/>
+          <p:cNvPicPr>
+            <a:picLocks noChangeAspect="1"/>
+          </p:cNvPicPr>
+          <p:nvPr/>
+        </p:nvPicPr>
+        <p:blipFill rotWithShape="1">
+          <a:blip r:embed="rId2"/>
+          <a:srcRect l="8001" r="7400" b="13000"/>
+          <a:stretch/>
+        </p:blipFill>
+        <p:spPr>
+          <a:xfrm>
+            <a:off x="1466850" y="-257175"/>
+            <a:ext cx="8058150" cy="3314700"/>
+          </a:xfrm>
+          <a:prstGeom prst="rect">
+            <a:avLst/>
+          </a:prstGeom>
+        </p:spPr>
+      </p:pic>
+      <p:pic>
+        <p:nvPicPr>
+          <p:cNvPr id="6" name="Picture 5"/>
+          <p:cNvPicPr>
+            <a:picLocks noChangeAspect="1"/>
+          </p:cNvPicPr>
+          <p:nvPr/>
+        </p:nvPicPr>
+        <p:blipFill rotWithShape="1">
+          <a:blip r:embed="rId3"/>
+          <a:srcRect l="8500" r="7500"/>
+          <a:stretch/>
+        </p:blipFill>
+        <p:spPr>
+          <a:xfrm>
+            <a:off x="1514475" y="3052763"/>
+            <a:ext cx="8001000" cy="3810000"/>
+          </a:xfrm>
+          <a:prstGeom prst="rect">
+            <a:avLst/>
+          </a:prstGeom>
+        </p:spPr>
+      </p:pic>
+      <p:pic>
+        <p:nvPicPr>
+          <p:cNvPr id="9" name="Picture 8"/>
+          <p:cNvPicPr>
+            <a:picLocks noChangeAspect="1"/>
+          </p:cNvPicPr>
+          <p:nvPr/>
+        </p:nvPicPr>
+        <p:blipFill rotWithShape="1">
+          <a:blip r:embed="rId2"/>
+          <a:srcRect l="4425" r="91700" b="13000"/>
+          <a:stretch/>
+        </p:blipFill>
+        <p:spPr>
+          <a:xfrm>
+            <a:off x="1145381" y="-172897"/>
+            <a:ext cx="369094" cy="3314700"/>
+          </a:xfrm>
+          <a:prstGeom prst="rect">
+            <a:avLst/>
+          </a:prstGeom>
+        </p:spPr>
+      </p:pic>
+      <p:pic>
+        <p:nvPicPr>
+          <p:cNvPr id="11" name="Picture 10"/>
+          <p:cNvPicPr>
+            <a:picLocks noChangeAspect="1"/>
+          </p:cNvPicPr>
+          <p:nvPr/>
+        </p:nvPicPr>
+        <p:blipFill rotWithShape="1">
+          <a:blip r:embed="rId2"/>
+          <a:srcRect l="4425" r="91700" b="13000"/>
+          <a:stretch/>
+        </p:blipFill>
+        <p:spPr>
+          <a:xfrm>
+            <a:off x="1145381" y="3108466"/>
+            <a:ext cx="369094" cy="3314700"/>
+          </a:xfrm>
+          <a:prstGeom prst="rect">
+            <a:avLst/>
+          </a:prstGeom>
+        </p:spPr>
+      </p:pic>
+    </p:spTree>
+    <p:extLst>
+      <p:ext uri="{BB962C8B-B14F-4D97-AF65-F5344CB8AC3E}">
+        <p14:creationId xmlns:p14="http://schemas.microsoft.com/office/powerpoint/2010/main" val="2519369938"/>
       </p:ext>
     </p:extLst>
   </p:cSld>

</xml_diff>

<commit_message>
experimental figures were updated, and finalized the paper and cover letter
</commit_message>
<xml_diff>
--- a/Switching Function - Reduced CMV PWM/Access-paper/Imperix/raw_data/New Microsoft PowerPoint Presentation.pptx
+++ b/Switching Function - Reduced CMV PWM/Access-paper/Imperix/raw_data/New Microsoft PowerPoint Presentation.pptx
@@ -8,8 +8,12 @@
     <p:sldId id="256" r:id="rId2"/>
     <p:sldId id="257" r:id="rId3"/>
     <p:sldId id="260" r:id="rId4"/>
-    <p:sldId id="258" r:id="rId5"/>
-    <p:sldId id="259" r:id="rId6"/>
+    <p:sldId id="262" r:id="rId5"/>
+    <p:sldId id="263" r:id="rId6"/>
+    <p:sldId id="264" r:id="rId7"/>
+    <p:sldId id="258" r:id="rId8"/>
+    <p:sldId id="259" r:id="rId9"/>
+    <p:sldId id="261" r:id="rId10"/>
   </p:sldIdLst>
   <p:sldSz cx="12192000" cy="6858000"/>
   <p:notesSz cx="6858000" cy="9144000"/>
@@ -108,6 +112,11 @@
       </a:defRPr>
     </a:lvl9pPr>
   </p:defaultTextStyle>
+  <p:extLst>
+    <p:ext uri="{EFAFB233-063F-42B5-8137-9DF3F51BA10A}">
+      <p15:sldGuideLst xmlns:p15="http://schemas.microsoft.com/office/powerpoint/2012/main"/>
+    </p:ext>
+  </p:extLst>
 </p:presentation>
 </file>
 
@@ -3458,9 +3467,81 @@
           <a:chExt cx="0" cy="0"/>
         </a:xfrm>
       </p:grpSpPr>
+      <p:sp>
+        <p:nvSpPr>
+          <p:cNvPr id="7" name="TextBox 6"/>
+          <p:cNvSpPr txBox="1"/>
+          <p:nvPr/>
+        </p:nvSpPr>
+        <p:spPr>
+          <a:xfrm>
+            <a:off x="5397500" y="2963723"/>
+            <a:ext cx="632460" cy="400110"/>
+          </a:xfrm>
+          <a:prstGeom prst="rect">
+            <a:avLst/>
+          </a:prstGeom>
+          <a:noFill/>
+        </p:spPr>
+        <p:txBody>
+          <a:bodyPr wrap="square" rtlCol="0">
+            <a:spAutoFit/>
+          </a:bodyPr>
+          <a:lstStyle/>
+          <a:p>
+            <a:r>
+              <a:rPr lang="en-US" sz="2000" dirty="0" smtClean="0">
+                <a:latin typeface="Times New Roman" panose="02020603050405020304" pitchFamily="18" charset="0"/>
+                <a:cs typeface="Times New Roman" panose="02020603050405020304" pitchFamily="18" charset="0"/>
+              </a:rPr>
+              <a:t>(a)</a:t>
+            </a:r>
+            <a:endParaRPr lang="sv-SE" sz="2000" dirty="0">
+              <a:latin typeface="Times New Roman" panose="02020603050405020304" pitchFamily="18" charset="0"/>
+              <a:cs typeface="Times New Roman" panose="02020603050405020304" pitchFamily="18" charset="0"/>
+            </a:endParaRPr>
+          </a:p>
+        </p:txBody>
+      </p:sp>
+      <p:sp>
+        <p:nvSpPr>
+          <p:cNvPr id="8" name="TextBox 7"/>
+          <p:cNvSpPr txBox="1"/>
+          <p:nvPr/>
+        </p:nvSpPr>
+        <p:spPr>
+          <a:xfrm>
+            <a:off x="5397500" y="6858000"/>
+            <a:ext cx="632460" cy="400110"/>
+          </a:xfrm>
+          <a:prstGeom prst="rect">
+            <a:avLst/>
+          </a:prstGeom>
+          <a:noFill/>
+        </p:spPr>
+        <p:txBody>
+          <a:bodyPr wrap="square" rtlCol="0">
+            <a:spAutoFit/>
+          </a:bodyPr>
+          <a:lstStyle/>
+          <a:p>
+            <a:r>
+              <a:rPr lang="en-US" sz="2000" dirty="0" smtClean="0">
+                <a:latin typeface="Times New Roman" panose="02020603050405020304" pitchFamily="18" charset="0"/>
+                <a:cs typeface="Times New Roman" panose="02020603050405020304" pitchFamily="18" charset="0"/>
+              </a:rPr>
+              <a:t>(b)</a:t>
+            </a:r>
+            <a:endParaRPr lang="sv-SE" sz="2000" dirty="0">
+              <a:latin typeface="Times New Roman" panose="02020603050405020304" pitchFamily="18" charset="0"/>
+              <a:cs typeface="Times New Roman" panose="02020603050405020304" pitchFamily="18" charset="0"/>
+            </a:endParaRPr>
+          </a:p>
+        </p:txBody>
+      </p:sp>
       <p:pic>
         <p:nvPicPr>
-          <p:cNvPr id="4" name="Picture 3"/>
+          <p:cNvPr id="2" name="Picture 1"/>
           <p:cNvPicPr>
             <a:picLocks noChangeAspect="1"/>
           </p:cNvPicPr>
@@ -3468,13 +3549,82 @@
         </p:nvPicPr>
         <p:blipFill rotWithShape="1">
           <a:blip r:embed="rId2"/>
-          <a:srcRect l="5700" t="5250" r="7700"/>
+          <a:srcRect l="8801" t="6741" r="8299" b="15250"/>
           <a:stretch/>
         </p:blipFill>
         <p:spPr>
           <a:xfrm>
-            <a:off x="1876424" y="1724024"/>
-            <a:ext cx="8248651" cy="3609975"/>
+            <a:off x="1552575" y="9525"/>
+            <a:ext cx="7896225" cy="2972137"/>
+          </a:xfrm>
+          <a:prstGeom prst="rect">
+            <a:avLst/>
+          </a:prstGeom>
+        </p:spPr>
+      </p:pic>
+      <p:pic>
+        <p:nvPicPr>
+          <p:cNvPr id="9" name="Picture 8"/>
+          <p:cNvPicPr>
+            <a:picLocks noChangeAspect="1"/>
+          </p:cNvPicPr>
+          <p:nvPr/>
+        </p:nvPicPr>
+        <p:blipFill rotWithShape="1">
+          <a:blip r:embed="rId2"/>
+          <a:srcRect l="5201" t="6741" r="91299" b="15250"/>
+          <a:stretch/>
+        </p:blipFill>
+        <p:spPr>
+          <a:xfrm>
+            <a:off x="1095375" y="-15195"/>
+            <a:ext cx="333375" cy="2972137"/>
+          </a:xfrm>
+          <a:prstGeom prst="rect">
+            <a:avLst/>
+          </a:prstGeom>
+        </p:spPr>
+      </p:pic>
+      <p:pic>
+        <p:nvPicPr>
+          <p:cNvPr id="10" name="Picture 9"/>
+          <p:cNvPicPr>
+            <a:picLocks noChangeAspect="1"/>
+          </p:cNvPicPr>
+          <p:nvPr/>
+        </p:nvPicPr>
+        <p:blipFill rotWithShape="1">
+          <a:blip r:embed="rId2"/>
+          <a:srcRect l="5201" t="6741" r="91299" b="15250"/>
+          <a:stretch/>
+        </p:blipFill>
+        <p:spPr>
+          <a:xfrm>
+            <a:off x="1095375" y="3230116"/>
+            <a:ext cx="333375" cy="2972137"/>
+          </a:xfrm>
+          <a:prstGeom prst="rect">
+            <a:avLst/>
+          </a:prstGeom>
+        </p:spPr>
+      </p:pic>
+      <p:pic>
+        <p:nvPicPr>
+          <p:cNvPr id="3" name="Picture 2"/>
+          <p:cNvPicPr>
+            <a:picLocks noChangeAspect="1"/>
+          </p:cNvPicPr>
+          <p:nvPr/>
+        </p:nvPicPr>
+        <p:blipFill rotWithShape="1">
+          <a:blip r:embed="rId3"/>
+          <a:srcRect l="7036" r="8280"/>
+          <a:stretch/>
+        </p:blipFill>
+        <p:spPr>
+          <a:xfrm>
+            <a:off x="1382545" y="3048000"/>
+            <a:ext cx="8066255" cy="3810000"/>
           </a:xfrm>
           <a:prstGeom prst="rect">
             <a:avLst/>
@@ -3484,7 +3634,7 @@
     </p:spTree>
     <p:extLst>
       <p:ext uri="{BB962C8B-B14F-4D97-AF65-F5344CB8AC3E}">
-        <p14:creationId xmlns:p14="http://schemas.microsoft.com/office/powerpoint/2010/main" val="1669249909"/>
+        <p14:creationId xmlns:p14="http://schemas.microsoft.com/office/powerpoint/2010/main" val="978820471"/>
       </p:ext>
     </p:extLst>
   </p:cSld>
@@ -3585,7 +3735,7 @@
       </p:sp>
       <p:pic>
         <p:nvPicPr>
-          <p:cNvPr id="4" name="Picture 3"/>
+          <p:cNvPr id="2" name="Picture 1"/>
           <p:cNvPicPr>
             <a:picLocks noChangeAspect="1"/>
           </p:cNvPicPr>
@@ -3593,36 +3743,13 @@
         </p:nvPicPr>
         <p:blipFill rotWithShape="1">
           <a:blip r:embed="rId2"/>
-          <a:srcRect l="8001" r="7400" b="13000"/>
+          <a:srcRect l="8801" t="6741" r="8299" b="15250"/>
           <a:stretch/>
         </p:blipFill>
         <p:spPr>
           <a:xfrm>
-            <a:off x="1466850" y="-257175"/>
-            <a:ext cx="8058150" cy="3314700"/>
-          </a:xfrm>
-          <a:prstGeom prst="rect">
-            <a:avLst/>
-          </a:prstGeom>
-        </p:spPr>
-      </p:pic>
-      <p:pic>
-        <p:nvPicPr>
-          <p:cNvPr id="6" name="Picture 5"/>
-          <p:cNvPicPr>
-            <a:picLocks noChangeAspect="1"/>
-          </p:cNvPicPr>
-          <p:nvPr/>
-        </p:nvPicPr>
-        <p:blipFill rotWithShape="1">
-          <a:blip r:embed="rId3"/>
-          <a:srcRect l="8500" r="7500"/>
-          <a:stretch/>
-        </p:blipFill>
-        <p:spPr>
-          <a:xfrm>
-            <a:off x="1514475" y="3052763"/>
-            <a:ext cx="8001000" cy="3810000"/>
+            <a:off x="1552575" y="9525"/>
+            <a:ext cx="7896225" cy="2972137"/>
           </a:xfrm>
           <a:prstGeom prst="rect">
             <a:avLst/>
@@ -3639,13 +3766,609 @@
         </p:nvPicPr>
         <p:blipFill rotWithShape="1">
           <a:blip r:embed="rId2"/>
-          <a:srcRect l="4425" r="91700" b="13000"/>
+          <a:srcRect l="5201" t="6741" r="91299" b="15250"/>
           <a:stretch/>
         </p:blipFill>
         <p:spPr>
           <a:xfrm>
+            <a:off x="1095375" y="-15195"/>
+            <a:ext cx="333375" cy="2972137"/>
+          </a:xfrm>
+          <a:prstGeom prst="rect">
+            <a:avLst/>
+          </a:prstGeom>
+        </p:spPr>
+      </p:pic>
+      <p:pic>
+        <p:nvPicPr>
+          <p:cNvPr id="10" name="Picture 9"/>
+          <p:cNvPicPr>
+            <a:picLocks noChangeAspect="1"/>
+          </p:cNvPicPr>
+          <p:nvPr/>
+        </p:nvPicPr>
+        <p:blipFill rotWithShape="1">
+          <a:blip r:embed="rId2"/>
+          <a:srcRect l="5201" t="6741" r="91299" b="15250"/>
+          <a:stretch/>
+        </p:blipFill>
+        <p:spPr>
+          <a:xfrm>
+            <a:off x="1095375" y="3230116"/>
+            <a:ext cx="333375" cy="2972137"/>
+          </a:xfrm>
+          <a:prstGeom prst="rect">
+            <a:avLst/>
+          </a:prstGeom>
+        </p:spPr>
+      </p:pic>
+    </p:spTree>
+    <p:extLst>
+      <p:ext uri="{BB962C8B-B14F-4D97-AF65-F5344CB8AC3E}">
+        <p14:creationId xmlns:p14="http://schemas.microsoft.com/office/powerpoint/2010/main" val="101161799"/>
+      </p:ext>
+    </p:extLst>
+  </p:cSld>
+  <p:clrMapOvr>
+    <a:masterClrMapping/>
+  </p:clrMapOvr>
+</p:sld>
+</file>
+
+<file path=ppt/slides/slide6.xml><?xml version="1.0" encoding="utf-8"?>
+<p:sld xmlns:a="http://schemas.openxmlformats.org/drawingml/2006/main" xmlns:r="http://schemas.openxmlformats.org/officeDocument/2006/relationships" xmlns:p="http://schemas.openxmlformats.org/presentationml/2006/main">
+  <p:cSld>
+    <p:spTree>
+      <p:nvGrpSpPr>
+        <p:cNvPr id="1" name=""/>
+        <p:cNvGrpSpPr/>
+        <p:nvPr/>
+      </p:nvGrpSpPr>
+      <p:grpSpPr>
+        <a:xfrm>
+          <a:off x="0" y="0"/>
+          <a:ext cx="0" cy="0"/>
+          <a:chOff x="0" y="0"/>
+          <a:chExt cx="0" cy="0"/>
+        </a:xfrm>
+      </p:grpSpPr>
+      <p:sp>
+        <p:nvSpPr>
+          <p:cNvPr id="7" name="TextBox 6"/>
+          <p:cNvSpPr txBox="1"/>
+          <p:nvPr/>
+        </p:nvSpPr>
+        <p:spPr>
+          <a:xfrm>
+            <a:off x="5397500" y="2963723"/>
+            <a:ext cx="632460" cy="400110"/>
+          </a:xfrm>
+          <a:prstGeom prst="rect">
+            <a:avLst/>
+          </a:prstGeom>
+          <a:noFill/>
+        </p:spPr>
+        <p:txBody>
+          <a:bodyPr wrap="square" rtlCol="0">
+            <a:spAutoFit/>
+          </a:bodyPr>
+          <a:lstStyle/>
+          <a:p>
+            <a:r>
+              <a:rPr lang="en-US" sz="2000" dirty="0" smtClean="0">
+                <a:latin typeface="Times New Roman" panose="02020603050405020304" pitchFamily="18" charset="0"/>
+                <a:cs typeface="Times New Roman" panose="02020603050405020304" pitchFamily="18" charset="0"/>
+              </a:rPr>
+              <a:t>(a)</a:t>
+            </a:r>
+            <a:endParaRPr lang="sv-SE" sz="2000" dirty="0">
+              <a:latin typeface="Times New Roman" panose="02020603050405020304" pitchFamily="18" charset="0"/>
+              <a:cs typeface="Times New Roman" panose="02020603050405020304" pitchFamily="18" charset="0"/>
+            </a:endParaRPr>
+          </a:p>
+        </p:txBody>
+      </p:sp>
+      <p:sp>
+        <p:nvSpPr>
+          <p:cNvPr id="8" name="TextBox 7"/>
+          <p:cNvSpPr txBox="1"/>
+          <p:nvPr/>
+        </p:nvSpPr>
+        <p:spPr>
+          <a:xfrm>
+            <a:off x="5397500" y="6858000"/>
+            <a:ext cx="632460" cy="400110"/>
+          </a:xfrm>
+          <a:prstGeom prst="rect">
+            <a:avLst/>
+          </a:prstGeom>
+          <a:noFill/>
+        </p:spPr>
+        <p:txBody>
+          <a:bodyPr wrap="square" rtlCol="0">
+            <a:spAutoFit/>
+          </a:bodyPr>
+          <a:lstStyle/>
+          <a:p>
+            <a:r>
+              <a:rPr lang="en-US" sz="2000" dirty="0" smtClean="0">
+                <a:latin typeface="Times New Roman" panose="02020603050405020304" pitchFamily="18" charset="0"/>
+                <a:cs typeface="Times New Roman" panose="02020603050405020304" pitchFamily="18" charset="0"/>
+              </a:rPr>
+              <a:t>(b)</a:t>
+            </a:r>
+            <a:endParaRPr lang="sv-SE" sz="2000" dirty="0">
+              <a:latin typeface="Times New Roman" panose="02020603050405020304" pitchFamily="18" charset="0"/>
+              <a:cs typeface="Times New Roman" panose="02020603050405020304" pitchFamily="18" charset="0"/>
+            </a:endParaRPr>
+          </a:p>
+        </p:txBody>
+      </p:sp>
+      <p:pic>
+        <p:nvPicPr>
+          <p:cNvPr id="9" name="Picture 8"/>
+          <p:cNvPicPr>
+            <a:picLocks noChangeAspect="1"/>
+          </p:cNvPicPr>
+          <p:nvPr/>
+        </p:nvPicPr>
+        <p:blipFill rotWithShape="1">
+          <a:blip r:embed="rId2"/>
+          <a:srcRect l="5201" t="6741" r="91299" b="15250"/>
+          <a:stretch/>
+        </p:blipFill>
+        <p:spPr>
+          <a:xfrm>
+            <a:off x="1095375" y="-15195"/>
+            <a:ext cx="333375" cy="2972137"/>
+          </a:xfrm>
+          <a:prstGeom prst="rect">
+            <a:avLst/>
+          </a:prstGeom>
+        </p:spPr>
+      </p:pic>
+      <p:pic>
+        <p:nvPicPr>
+          <p:cNvPr id="10" name="Picture 9"/>
+          <p:cNvPicPr>
+            <a:picLocks noChangeAspect="1"/>
+          </p:cNvPicPr>
+          <p:nvPr/>
+        </p:nvPicPr>
+        <p:blipFill rotWithShape="1">
+          <a:blip r:embed="rId2"/>
+          <a:srcRect l="5201" t="6741" r="91299" b="15250"/>
+          <a:stretch/>
+        </p:blipFill>
+        <p:spPr>
+          <a:xfrm>
+            <a:off x="1095375" y="3230116"/>
+            <a:ext cx="333375" cy="2972137"/>
+          </a:xfrm>
+          <a:prstGeom prst="rect">
+            <a:avLst/>
+          </a:prstGeom>
+        </p:spPr>
+      </p:pic>
+      <p:pic>
+        <p:nvPicPr>
+          <p:cNvPr id="4" name="Picture 3"/>
+          <p:cNvPicPr>
+            <a:picLocks noChangeAspect="1"/>
+          </p:cNvPicPr>
+          <p:nvPr/>
+        </p:nvPicPr>
+        <p:blipFill rotWithShape="1">
+          <a:blip r:embed="rId3"/>
+          <a:srcRect l="7036" r="8109"/>
+          <a:stretch/>
+        </p:blipFill>
+        <p:spPr>
+          <a:xfrm>
+            <a:off x="1366344" y="3048000"/>
+            <a:ext cx="8082456" cy="3810000"/>
+          </a:xfrm>
+          <a:prstGeom prst="rect">
+            <a:avLst/>
+          </a:prstGeom>
+        </p:spPr>
+      </p:pic>
+      <p:pic>
+        <p:nvPicPr>
+          <p:cNvPr id="5" name="Picture 4"/>
+          <p:cNvPicPr>
+            <a:picLocks noChangeAspect="1"/>
+          </p:cNvPicPr>
+          <p:nvPr/>
+        </p:nvPicPr>
+        <p:blipFill rotWithShape="1">
+          <a:blip r:embed="rId4"/>
+          <a:srcRect l="8551" t="5793" r="7697" b="15862"/>
+          <a:stretch/>
+        </p:blipFill>
+        <p:spPr>
+          <a:xfrm>
+            <a:off x="1524788" y="63062"/>
+            <a:ext cx="7977352" cy="2984938"/>
+          </a:xfrm>
+          <a:prstGeom prst="rect">
+            <a:avLst/>
+          </a:prstGeom>
+        </p:spPr>
+      </p:pic>
+    </p:spTree>
+    <p:extLst>
+      <p:ext uri="{BB962C8B-B14F-4D97-AF65-F5344CB8AC3E}">
+        <p14:creationId xmlns:p14="http://schemas.microsoft.com/office/powerpoint/2010/main" val="4030573646"/>
+      </p:ext>
+    </p:extLst>
+  </p:cSld>
+  <p:clrMapOvr>
+    <a:masterClrMapping/>
+  </p:clrMapOvr>
+</p:sld>
+</file>
+
+<file path=ppt/slides/slide7.xml><?xml version="1.0" encoding="utf-8"?>
+<p:sld xmlns:a="http://schemas.openxmlformats.org/drawingml/2006/main" xmlns:r="http://schemas.openxmlformats.org/officeDocument/2006/relationships" xmlns:p="http://schemas.openxmlformats.org/presentationml/2006/main">
+  <p:cSld>
+    <p:spTree>
+      <p:nvGrpSpPr>
+        <p:cNvPr id="1" name=""/>
+        <p:cNvGrpSpPr/>
+        <p:nvPr/>
+      </p:nvGrpSpPr>
+      <p:grpSpPr>
+        <a:xfrm>
+          <a:off x="0" y="0"/>
+          <a:ext cx="0" cy="0"/>
+          <a:chOff x="0" y="0"/>
+          <a:chExt cx="0" cy="0"/>
+        </a:xfrm>
+      </p:grpSpPr>
+      <p:pic>
+        <p:nvPicPr>
+          <p:cNvPr id="4" name="Picture 3"/>
+          <p:cNvPicPr>
+            <a:picLocks noChangeAspect="1"/>
+          </p:cNvPicPr>
+          <p:nvPr/>
+        </p:nvPicPr>
+        <p:blipFill rotWithShape="1">
+          <a:blip r:embed="rId2"/>
+          <a:srcRect l="5700" t="5250" r="7700"/>
+          <a:stretch/>
+        </p:blipFill>
+        <p:spPr>
+          <a:xfrm>
+            <a:off x="1876424" y="1724024"/>
+            <a:ext cx="8248651" cy="3609975"/>
+          </a:xfrm>
+          <a:prstGeom prst="rect">
+            <a:avLst/>
+          </a:prstGeom>
+        </p:spPr>
+      </p:pic>
+    </p:spTree>
+    <p:extLst>
+      <p:ext uri="{BB962C8B-B14F-4D97-AF65-F5344CB8AC3E}">
+        <p14:creationId xmlns:p14="http://schemas.microsoft.com/office/powerpoint/2010/main" val="1669249909"/>
+      </p:ext>
+    </p:extLst>
+  </p:cSld>
+  <p:clrMapOvr>
+    <a:masterClrMapping/>
+  </p:clrMapOvr>
+</p:sld>
+</file>
+
+<file path=ppt/slides/slide8.xml><?xml version="1.0" encoding="utf-8"?>
+<p:sld xmlns:a="http://schemas.openxmlformats.org/drawingml/2006/main" xmlns:r="http://schemas.openxmlformats.org/officeDocument/2006/relationships" xmlns:p="http://schemas.openxmlformats.org/presentationml/2006/main">
+  <p:cSld>
+    <p:spTree>
+      <p:nvGrpSpPr>
+        <p:cNvPr id="1" name=""/>
+        <p:cNvGrpSpPr/>
+        <p:nvPr/>
+      </p:nvGrpSpPr>
+      <p:grpSpPr>
+        <a:xfrm>
+          <a:off x="0" y="0"/>
+          <a:ext cx="0" cy="0"/>
+          <a:chOff x="0" y="0"/>
+          <a:chExt cx="0" cy="0"/>
+        </a:xfrm>
+      </p:grpSpPr>
+      <p:sp>
+        <p:nvSpPr>
+          <p:cNvPr id="7" name="TextBox 6"/>
+          <p:cNvSpPr txBox="1"/>
+          <p:nvPr/>
+        </p:nvSpPr>
+        <p:spPr>
+          <a:xfrm>
+            <a:off x="5397500" y="2963723"/>
+            <a:ext cx="632460" cy="400110"/>
+          </a:xfrm>
+          <a:prstGeom prst="rect">
+            <a:avLst/>
+          </a:prstGeom>
+          <a:noFill/>
+        </p:spPr>
+        <p:txBody>
+          <a:bodyPr wrap="square" rtlCol="0">
+            <a:spAutoFit/>
+          </a:bodyPr>
+          <a:lstStyle/>
+          <a:p>
+            <a:r>
+              <a:rPr lang="en-US" sz="2000" dirty="0" smtClean="0">
+                <a:latin typeface="Times New Roman" panose="02020603050405020304" pitchFamily="18" charset="0"/>
+                <a:cs typeface="Times New Roman" panose="02020603050405020304" pitchFamily="18" charset="0"/>
+              </a:rPr>
+              <a:t>(a)</a:t>
+            </a:r>
+            <a:endParaRPr lang="sv-SE" sz="2000" dirty="0">
+              <a:latin typeface="Times New Roman" panose="02020603050405020304" pitchFamily="18" charset="0"/>
+              <a:cs typeface="Times New Roman" panose="02020603050405020304" pitchFamily="18" charset="0"/>
+            </a:endParaRPr>
+          </a:p>
+        </p:txBody>
+      </p:sp>
+      <p:sp>
+        <p:nvSpPr>
+          <p:cNvPr id="8" name="TextBox 7"/>
+          <p:cNvSpPr txBox="1"/>
+          <p:nvPr/>
+        </p:nvSpPr>
+        <p:spPr>
+          <a:xfrm>
+            <a:off x="5397500" y="6858000"/>
+            <a:ext cx="632460" cy="400110"/>
+          </a:xfrm>
+          <a:prstGeom prst="rect">
+            <a:avLst/>
+          </a:prstGeom>
+          <a:noFill/>
+        </p:spPr>
+        <p:txBody>
+          <a:bodyPr wrap="square" rtlCol="0">
+            <a:spAutoFit/>
+          </a:bodyPr>
+          <a:lstStyle/>
+          <a:p>
+            <a:r>
+              <a:rPr lang="en-US" sz="2000" dirty="0" smtClean="0">
+                <a:latin typeface="Times New Roman" panose="02020603050405020304" pitchFamily="18" charset="0"/>
+                <a:cs typeface="Times New Roman" panose="02020603050405020304" pitchFamily="18" charset="0"/>
+              </a:rPr>
+              <a:t>(b)</a:t>
+            </a:r>
+            <a:endParaRPr lang="sv-SE" sz="2000" dirty="0">
+              <a:latin typeface="Times New Roman" panose="02020603050405020304" pitchFamily="18" charset="0"/>
+              <a:cs typeface="Times New Roman" panose="02020603050405020304" pitchFamily="18" charset="0"/>
+            </a:endParaRPr>
+          </a:p>
+        </p:txBody>
+      </p:sp>
+      <p:pic>
+        <p:nvPicPr>
+          <p:cNvPr id="6" name="Picture 5"/>
+          <p:cNvPicPr>
+            <a:picLocks noChangeAspect="1"/>
+          </p:cNvPicPr>
+          <p:nvPr/>
+        </p:nvPicPr>
+        <p:blipFill rotWithShape="1">
+          <a:blip r:embed="rId2"/>
+          <a:srcRect l="8500" r="7753"/>
+          <a:stretch/>
+        </p:blipFill>
+        <p:spPr>
+          <a:xfrm>
+            <a:off x="1514475" y="3052763"/>
+            <a:ext cx="7976997" cy="3810000"/>
+          </a:xfrm>
+          <a:prstGeom prst="rect">
+            <a:avLst/>
+          </a:prstGeom>
+        </p:spPr>
+      </p:pic>
+      <p:pic>
+        <p:nvPicPr>
+          <p:cNvPr id="9" name="Picture 8"/>
+          <p:cNvPicPr>
+            <a:picLocks noChangeAspect="1"/>
+          </p:cNvPicPr>
+          <p:nvPr/>
+        </p:nvPicPr>
+        <p:blipFill rotWithShape="1">
+          <a:blip r:embed="rId3"/>
+          <a:srcRect l="4425" r="92336" b="13000"/>
+          <a:stretch/>
+        </p:blipFill>
+        <p:spPr>
+          <a:xfrm>
             <a:off x="1145381" y="-172897"/>
-            <a:ext cx="369094" cy="3314700"/>
+            <a:ext cx="308515" cy="3314700"/>
+          </a:xfrm>
+          <a:prstGeom prst="rect">
+            <a:avLst/>
+          </a:prstGeom>
+        </p:spPr>
+      </p:pic>
+      <p:pic>
+        <p:nvPicPr>
+          <p:cNvPr id="11" name="Picture 10"/>
+          <p:cNvPicPr>
+            <a:picLocks noChangeAspect="1"/>
+          </p:cNvPicPr>
+          <p:nvPr/>
+        </p:nvPicPr>
+        <p:blipFill rotWithShape="1">
+          <a:blip r:embed="rId3"/>
+          <a:srcRect l="4425" r="92144" b="13000"/>
+          <a:stretch/>
+        </p:blipFill>
+        <p:spPr>
+          <a:xfrm>
+            <a:off x="1145381" y="3108466"/>
+            <a:ext cx="326803" cy="3314700"/>
+          </a:xfrm>
+          <a:prstGeom prst="rect">
+            <a:avLst/>
+          </a:prstGeom>
+        </p:spPr>
+      </p:pic>
+      <p:pic>
+        <p:nvPicPr>
+          <p:cNvPr id="2" name="Picture 1"/>
+          <p:cNvPicPr>
+            <a:picLocks noChangeAspect="1"/>
+          </p:cNvPicPr>
+          <p:nvPr/>
+        </p:nvPicPr>
+        <p:blipFill rotWithShape="1">
+          <a:blip r:embed="rId4"/>
+          <a:srcRect l="7556" t="5408" r="8792" b="14535"/>
+          <a:stretch/>
+        </p:blipFill>
+        <p:spPr>
+          <a:xfrm>
+            <a:off x="1413573" y="2573"/>
+            <a:ext cx="7967854" cy="3050190"/>
+          </a:xfrm>
+          <a:prstGeom prst="rect">
+            <a:avLst/>
+          </a:prstGeom>
+        </p:spPr>
+      </p:pic>
+    </p:spTree>
+    <p:extLst>
+      <p:ext uri="{BB962C8B-B14F-4D97-AF65-F5344CB8AC3E}">
+        <p14:creationId xmlns:p14="http://schemas.microsoft.com/office/powerpoint/2010/main" val="2519369938"/>
+      </p:ext>
+    </p:extLst>
+  </p:cSld>
+  <p:clrMapOvr>
+    <a:masterClrMapping/>
+  </p:clrMapOvr>
+  <p:timing>
+    <p:tnLst>
+      <p:par>
+        <p:cTn id="1" dur="indefinite" restart="never" nodeType="tmRoot"/>
+      </p:par>
+    </p:tnLst>
+  </p:timing>
+</p:sld>
+</file>
+
+<file path=ppt/slides/slide9.xml><?xml version="1.0" encoding="utf-8"?>
+<p:sld xmlns:a="http://schemas.openxmlformats.org/drawingml/2006/main" xmlns:r="http://schemas.openxmlformats.org/officeDocument/2006/relationships" xmlns:p="http://schemas.openxmlformats.org/presentationml/2006/main">
+  <p:cSld>
+    <p:spTree>
+      <p:nvGrpSpPr>
+        <p:cNvPr id="1" name=""/>
+        <p:cNvGrpSpPr/>
+        <p:nvPr/>
+      </p:nvGrpSpPr>
+      <p:grpSpPr>
+        <a:xfrm>
+          <a:off x="0" y="0"/>
+          <a:ext cx="0" cy="0"/>
+          <a:chOff x="0" y="0"/>
+          <a:chExt cx="0" cy="0"/>
+        </a:xfrm>
+      </p:grpSpPr>
+      <p:sp>
+        <p:nvSpPr>
+          <p:cNvPr id="7" name="TextBox 6"/>
+          <p:cNvSpPr txBox="1"/>
+          <p:nvPr/>
+        </p:nvSpPr>
+        <p:spPr>
+          <a:xfrm>
+            <a:off x="5397500" y="2963723"/>
+            <a:ext cx="632460" cy="400110"/>
+          </a:xfrm>
+          <a:prstGeom prst="rect">
+            <a:avLst/>
+          </a:prstGeom>
+          <a:noFill/>
+        </p:spPr>
+        <p:txBody>
+          <a:bodyPr wrap="square" rtlCol="0">
+            <a:spAutoFit/>
+          </a:bodyPr>
+          <a:lstStyle/>
+          <a:p>
+            <a:r>
+              <a:rPr lang="en-US" sz="2000" dirty="0" smtClean="0">
+                <a:latin typeface="Times New Roman" panose="02020603050405020304" pitchFamily="18" charset="0"/>
+                <a:cs typeface="Times New Roman" panose="02020603050405020304" pitchFamily="18" charset="0"/>
+              </a:rPr>
+              <a:t>(a)</a:t>
+            </a:r>
+            <a:endParaRPr lang="sv-SE" sz="2000" dirty="0">
+              <a:latin typeface="Times New Roman" panose="02020603050405020304" pitchFamily="18" charset="0"/>
+              <a:cs typeface="Times New Roman" panose="02020603050405020304" pitchFamily="18" charset="0"/>
+            </a:endParaRPr>
+          </a:p>
+        </p:txBody>
+      </p:sp>
+      <p:sp>
+        <p:nvSpPr>
+          <p:cNvPr id="8" name="TextBox 7"/>
+          <p:cNvSpPr txBox="1"/>
+          <p:nvPr/>
+        </p:nvSpPr>
+        <p:spPr>
+          <a:xfrm>
+            <a:off x="5397500" y="6858000"/>
+            <a:ext cx="632460" cy="400110"/>
+          </a:xfrm>
+          <a:prstGeom prst="rect">
+            <a:avLst/>
+          </a:prstGeom>
+          <a:noFill/>
+        </p:spPr>
+        <p:txBody>
+          <a:bodyPr wrap="square" rtlCol="0">
+            <a:spAutoFit/>
+          </a:bodyPr>
+          <a:lstStyle/>
+          <a:p>
+            <a:r>
+              <a:rPr lang="en-US" sz="2000" dirty="0" smtClean="0">
+                <a:latin typeface="Times New Roman" panose="02020603050405020304" pitchFamily="18" charset="0"/>
+                <a:cs typeface="Times New Roman" panose="02020603050405020304" pitchFamily="18" charset="0"/>
+              </a:rPr>
+              <a:t>(b)</a:t>
+            </a:r>
+            <a:endParaRPr lang="sv-SE" sz="2000" dirty="0">
+              <a:latin typeface="Times New Roman" panose="02020603050405020304" pitchFamily="18" charset="0"/>
+              <a:cs typeface="Times New Roman" panose="02020603050405020304" pitchFamily="18" charset="0"/>
+            </a:endParaRPr>
+          </a:p>
+        </p:txBody>
+      </p:sp>
+      <p:pic>
+        <p:nvPicPr>
+          <p:cNvPr id="9" name="Picture 8"/>
+          <p:cNvPicPr>
+            <a:picLocks noChangeAspect="1"/>
+          </p:cNvPicPr>
+          <p:nvPr/>
+        </p:nvPicPr>
+        <p:blipFill rotWithShape="1">
+          <a:blip r:embed="rId2"/>
+          <a:srcRect l="4425" r="92336" b="13000"/>
+          <a:stretch/>
+        </p:blipFill>
+        <p:spPr>
+          <a:xfrm>
+            <a:off x="1145381" y="-172897"/>
+            <a:ext cx="308515" cy="3314700"/>
           </a:xfrm>
           <a:prstGeom prst="rect">
             <a:avLst/>
@@ -3662,13 +4385,59 @@
         </p:nvPicPr>
         <p:blipFill rotWithShape="1">
           <a:blip r:embed="rId2"/>
-          <a:srcRect l="4425" r="91700" b="13000"/>
+          <a:srcRect l="4425" r="92144" b="13000"/>
           <a:stretch/>
         </p:blipFill>
         <p:spPr>
           <a:xfrm>
             <a:off x="1145381" y="3108466"/>
-            <a:ext cx="369094" cy="3314700"/>
+            <a:ext cx="326803" cy="3314700"/>
+          </a:xfrm>
+          <a:prstGeom prst="rect">
+            <a:avLst/>
+          </a:prstGeom>
+        </p:spPr>
+      </p:pic>
+      <p:pic>
+        <p:nvPicPr>
+          <p:cNvPr id="2" name="Picture 1"/>
+          <p:cNvPicPr>
+            <a:picLocks noChangeAspect="1"/>
+          </p:cNvPicPr>
+          <p:nvPr/>
+        </p:nvPicPr>
+        <p:blipFill rotWithShape="1">
+          <a:blip r:embed="rId3"/>
+          <a:srcRect l="7556" t="5408" r="8792" b="14535"/>
+          <a:stretch/>
+        </p:blipFill>
+        <p:spPr>
+          <a:xfrm>
+            <a:off x="1413573" y="2573"/>
+            <a:ext cx="7967854" cy="3050190"/>
+          </a:xfrm>
+          <a:prstGeom prst="rect">
+            <a:avLst/>
+          </a:prstGeom>
+        </p:spPr>
+      </p:pic>
+      <p:pic>
+        <p:nvPicPr>
+          <p:cNvPr id="3" name="Picture 2"/>
+          <p:cNvPicPr>
+            <a:picLocks noChangeAspect="1"/>
+          </p:cNvPicPr>
+          <p:nvPr/>
+        </p:nvPicPr>
+        <p:blipFill rotWithShape="1">
+          <a:blip r:embed="rId4"/>
+          <a:srcRect l="8597" r="7307"/>
+          <a:stretch/>
+        </p:blipFill>
+        <p:spPr>
+          <a:xfrm>
+            <a:off x="1545336" y="3108466"/>
+            <a:ext cx="8010144" cy="3810000"/>
           </a:xfrm>
           <a:prstGeom prst="rect">
             <a:avLst/>
@@ -3678,13 +4447,20 @@
     </p:spTree>
     <p:extLst>
       <p:ext uri="{BB962C8B-B14F-4D97-AF65-F5344CB8AC3E}">
-        <p14:creationId xmlns:p14="http://schemas.microsoft.com/office/powerpoint/2010/main" val="2519369938"/>
+        <p14:creationId xmlns:p14="http://schemas.microsoft.com/office/powerpoint/2010/main" val="3734523846"/>
       </p:ext>
     </p:extLst>
   </p:cSld>
   <p:clrMapOvr>
     <a:masterClrMapping/>
   </p:clrMapOvr>
+  <p:timing>
+    <p:tnLst>
+      <p:par>
+        <p:cTn id="1" dur="indefinite" restart="never" nodeType="tmRoot"/>
+      </p:par>
+    </p:tnLst>
+  </p:timing>
 </p:sld>
 </file>
 

</xml_diff>